<commit_message>
auto(analyze): portfolio PPT 2026-06-30T23:55:14Z
</commit_message>
<xml_diff>
--- a/reports/portfolio/2026-07-01.pptx
+++ b/reports/portfolio/2026-07-01.pptx
@@ -3192,7 +3192,7 @@
                   <a:srgbClr val="555555"/>
                 </a:solidFill>
               </a:rPr>
-              <a:t>분석 기간: 2026-06-29 00:00 ~ 2026-06-30 23:30</a:t>
+              <a:t>분석 기간: 2026-06-29 00:00 ~ 2026-07-01 08:45</a:t>
             </a:r>
           </a:p>
           <a:p>
@@ -3203,7 +3203,7 @@
                   <a:srgbClr val="555555"/>
                 </a:solidFill>
               </a:rPr>
-              <a:t>데이터: 총 571건 · 5분 해상도 · 전국 계통 기준</a:t>
+              <a:t>데이터: 총 682건 · 5분 해상도 · 전국 계통 기준</a:t>
             </a:r>
           </a:p>
           <a:p>
@@ -3214,7 +3214,7 @@
                   <a:srgbClr val="555555"/>
                 </a:solidFill>
               </a:rPr>
-              <a:t>생성일: 2026-07-01 07:47 KST</a:t>
+              <a:t>생성일: 2026-07-01 08:55 KST</a:t>
             </a:r>
           </a:p>
         </p:txBody>
@@ -4059,7 +4059,7 @@
                   <a:srgbClr val="555555"/>
                 </a:solidFill>
               </a:rPr>
-              <a:t>•  총 571건 · 48시간 분량 5분 해상도 수집·분석</a:t>
+              <a:t>•  총 682건 · 57시간 분량 5분 해상도 수집·분석</a:t>
             </a:r>
           </a:p>
           <a:p>
@@ -4074,7 +4074,7 @@
                   <a:srgbClr val="555555"/>
                 </a:solidFill>
               </a:rPr>
-              <a:t>•  다층 이상탐지 결과: EWMA:2건 · CUSUM:41건 · IForest:0건 · 잔차:0건 · LSTM-AE:스킵</a:t>
+              <a:t>•  다층 이상탐지 결과: EWMA:2건 · CUSUM:48건 · IForest:0건 · 잔차:0건 · LSTM-AE:스킵</a:t>
             </a:r>
           </a:p>
           <a:p>

</xml_diff>